<commit_message>
Redistribute figures: A1 keeps 4 theory figures, remove 5 application figures to A2
A1 (JMLR theory) now has:
- Figure 1: fig1_three_approaches.png (new, added to intro)
- Figure 2: fig2_magnetic_laplacian_q.png (magnetic Laplacian eigenvectors)
- Figure 3: fig3_hodge_decomposition.png (Hodge decomposition)
- Figure 4: fig8_alpha_sweep.png (alpha-sweep phase transition)

Removed from A1 (moved to A2 applied paper):
- fig4_direction_comparison.png
- fig5_hill_radar.png
- fig6_causal_dag.png
- fig7_lingam_vs_spectral.png
- fig9_ecd_pruning_analysis.png

Updated: LaTeX cross-references, docx generator, pptx generator.
Regenerated: spectral_causality_ja.docx (4 figures), spectral_causality_figures.pptx (4 slides).
LaTeX compiles cleanly: 23 pages, 0 undefined references.

Co-Authored-By: Tatsuki Onishi <bougtoir@gmail.com>
</commit_message>
<xml_diff>
--- a/spectral-causality-jmlr/spectral_causality_figures.pptx
+++ b/spectral-causality-jmlr/spectral_causality_figures.pptx
@@ -9,11 +9,6 @@
     <p:sldId id="257" r:id="rId8"/>
     <p:sldId id="258" r:id="rId9"/>
     <p:sldId id="259" r:id="rId10"/>
-    <p:sldId id="260" r:id="rId11"/>
-    <p:sldId id="261" r:id="rId12"/>
-    <p:sldId id="262" r:id="rId13"/>
-    <p:sldId id="263" r:id="rId14"/>
-    <p:sldId id="264" r:id="rId15"/>
   </p:sldIdLst>
   <p:sldSz cx="12191695" cy="6858000" type="screen4x3"/>
   <p:notesSz cx="6858000" cy="9144000"/>
@@ -3122,14 +3117,14 @@
               <a:defRPr sz="2000" b="1"/>
             </a:pPr>
             <a:r>
-              <a:t>Figure 1: DirectLiNGAM Estimated Causal DAG</a:t>
+              <a:t>Figure 1: Three Approaches to Causal Inference</a:t>
             </a:r>
           </a:p>
         </p:txBody>
       </p:sp>
       <p:pic>
         <p:nvPicPr>
-          <p:cNvPr id="3" name="Picture 2" descr="fig6_causal_dag.png"/>
+          <p:cNvPr id="3" name="Picture 2" descr="fig1_three_approaches.png"/>
           <p:cNvPicPr>
             <a:picLocks noChangeAspect="1"/>
           </p:cNvPicPr>
@@ -3177,7 +3172,7 @@
               <a:defRPr sz="1200" i="1"/>
             </a:pPr>
             <a:r>
-              <a:t>DirectLiNGAM estimated causal DAG for the UCI Heart Disease data (N=297, 5 clinical variables). Blue edges indicate positive causal effects; red edges indicate negative effects. Age is the most upstream variable.</a:t>
+              <a:t>Three complementary approaches to causal inference: (1) structural equation models and DAG-based methods (e.g., LiNGAM), (2) spectral graph methods via the magnetic Laplacian, and (3) Hodge-theoretic flow decomposition. Spectral causality unifies (2) and (3).</a:t>
             </a:r>
           </a:p>
         </p:txBody>
@@ -3434,423 +3429,7 @@
               <a:defRPr sz="2000" b="1"/>
             </a:pPr>
             <a:r>
-              <a:t>Figure 4: Causal Direction Comparison</a:t>
-            </a:r>
-          </a:p>
-        </p:txBody>
-      </p:sp>
-      <p:pic>
-        <p:nvPicPr>
-          <p:cNvPr id="3" name="Picture 2" descr="fig4_direction_comparison.png"/>
-          <p:cNvPicPr>
-            <a:picLocks noChangeAspect="1"/>
-          </p:cNvPicPr>
-          <p:nvPr/>
-        </p:nvPicPr>
-        <p:blipFill>
-          <a:blip r:embed="rId2"/>
-          <a:stretch>
-            <a:fillRect/>
-          </a:stretch>
-        </p:blipFill>
-        <p:spPr>
-          <a:xfrm>
-            <a:off x="1371600" y="914400"/>
-            <a:ext cx="9448495" cy="4572000"/>
-          </a:xfrm>
-          <a:prstGeom prst="rect">
-            <a:avLst/>
-          </a:prstGeom>
-        </p:spPr>
-      </p:pic>
-      <p:sp>
-        <p:nvSpPr>
-          <p:cNvPr id="4" name="TextBox 3"/>
-          <p:cNvSpPr txBox="1"/>
-          <p:nvPr/>
-        </p:nvSpPr>
-        <p:spPr>
-          <a:xfrm>
-            <a:off x="457200" y="5669280"/>
-            <a:ext cx="11277295" cy="914400"/>
-          </a:xfrm>
-          <a:prstGeom prst="rect">
-            <a:avLst/>
-          </a:prstGeom>
-          <a:noFill/>
-        </p:spPr>
-        <p:txBody>
-          <a:bodyPr wrap="square">
-            <a:spAutoFit/>
-          </a:bodyPr>
-          <a:lstStyle/>
-          <a:p>
-            <a:pPr algn="ctr">
-              <a:defRPr sz="1200" i="1"/>
-            </a:pPr>
-            <a:r>
-              <a:t>Causal direction comparison across all 10 variable pairs. LiNGAM (red), SCD (blue), Hodge potential (green). +1: first variable causes second; -1: reverse. Green background: all three methods agree.</a:t>
-            </a:r>
-          </a:p>
-        </p:txBody>
-      </p:sp>
-    </p:spTree>
-  </p:cSld>
-  <p:clrMapOvr>
-    <a:masterClrMapping/>
-  </p:clrMapOvr>
-</p:sld>
-</file>
-
-<file path=ppt/slides/slide5.xml><?xml version="1.0" encoding="utf-8"?>
-<p:sld xmlns:a="http://schemas.openxmlformats.org/drawingml/2006/main" xmlns:p="http://schemas.openxmlformats.org/presentationml/2006/main" xmlns:r="http://schemas.openxmlformats.org/officeDocument/2006/relationships">
-  <p:cSld>
-    <p:spTree>
-      <p:nvGrpSpPr>
-        <p:cNvPr id="1" name=""/>
-        <p:cNvGrpSpPr/>
-        <p:nvPr/>
-      </p:nvGrpSpPr>
-      <p:grpSpPr/>
-      <p:sp>
-        <p:nvSpPr>
-          <p:cNvPr id="2" name="TextBox 1"/>
-          <p:cNvSpPr txBox="1"/>
-          <p:nvPr/>
-        </p:nvSpPr>
-        <p:spPr>
-          <a:xfrm>
-            <a:off x="457200" y="182880"/>
-            <a:ext cx="11277295" cy="548640"/>
-          </a:xfrm>
-          <a:prstGeom prst="rect">
-            <a:avLst/>
-          </a:prstGeom>
-          <a:noFill/>
-        </p:spPr>
-        <p:txBody>
-          <a:bodyPr wrap="square">
-            <a:spAutoFit/>
-          </a:bodyPr>
-          <a:lstStyle/>
-          <a:p>
-            <a:pPr algn="ctr">
-              <a:defRPr sz="2000" b="1"/>
-            </a:pPr>
-            <a:r>
-              <a:t>Figure 5: Hill's Nine Criteria Coverage</a:t>
-            </a:r>
-          </a:p>
-        </p:txBody>
-      </p:sp>
-      <p:pic>
-        <p:nvPicPr>
-          <p:cNvPr id="3" name="Picture 2" descr="fig5_hill_radar.png"/>
-          <p:cNvPicPr>
-            <a:picLocks noChangeAspect="1"/>
-          </p:cNvPicPr>
-          <p:nvPr/>
-        </p:nvPicPr>
-        <p:blipFill>
-          <a:blip r:embed="rId2"/>
-          <a:stretch>
-            <a:fillRect/>
-          </a:stretch>
-        </p:blipFill>
-        <p:spPr>
-          <a:xfrm>
-            <a:off x="1371600" y="914400"/>
-            <a:ext cx="9448495" cy="4572000"/>
-          </a:xfrm>
-          <a:prstGeom prst="rect">
-            <a:avLst/>
-          </a:prstGeom>
-        </p:spPr>
-      </p:pic>
-      <p:sp>
-        <p:nvSpPr>
-          <p:cNvPr id="4" name="TextBox 3"/>
-          <p:cNvSpPr txBox="1"/>
-          <p:nvPr/>
-        </p:nvSpPr>
-        <p:spPr>
-          <a:xfrm>
-            <a:off x="457200" y="5669280"/>
-            <a:ext cx="11277295" cy="914400"/>
-          </a:xfrm>
-          <a:prstGeom prst="rect">
-            <a:avLst/>
-          </a:prstGeom>
-          <a:noFill/>
-        </p:spPr>
-        <p:txBody>
-          <a:bodyPr wrap="square">
-            <a:spAutoFit/>
-          </a:bodyPr>
-          <a:lstStyle/>
-          <a:p>
-            <a:pPr algn="ctr">
-              <a:defRPr sz="1200" i="1"/>
-            </a:pPr>
-            <a:r>
-              <a:t>Hill's nine criteria coverage. LiNGAM covers H1 (strength) and H3 (specificity) well but lacks H6/H7/H9. Spectral causality covers H6 (plausibility), H7 (coherence), H9 (analogy) via the utility function. The ECD ensemble achieves near-complete coverage.</a:t>
-            </a:r>
-          </a:p>
-        </p:txBody>
-      </p:sp>
-    </p:spTree>
-  </p:cSld>
-  <p:clrMapOvr>
-    <a:masterClrMapping/>
-  </p:clrMapOvr>
-</p:sld>
-</file>
-
-<file path=ppt/slides/slide6.xml><?xml version="1.0" encoding="utf-8"?>
-<p:sld xmlns:a="http://schemas.openxmlformats.org/drawingml/2006/main" xmlns:p="http://schemas.openxmlformats.org/presentationml/2006/main" xmlns:r="http://schemas.openxmlformats.org/officeDocument/2006/relationships">
-  <p:cSld>
-    <p:spTree>
-      <p:nvGrpSpPr>
-        <p:cNvPr id="1" name=""/>
-        <p:cNvGrpSpPr/>
-        <p:nvPr/>
-      </p:nvGrpSpPr>
-      <p:grpSpPr/>
-      <p:sp>
-        <p:nvSpPr>
-          <p:cNvPr id="2" name="TextBox 1"/>
-          <p:cNvSpPr txBox="1"/>
-          <p:nvPr/>
-        </p:nvSpPr>
-        <p:spPr>
-          <a:xfrm>
-            <a:off x="457200" y="182880"/>
-            <a:ext cx="11277295" cy="548640"/>
-          </a:xfrm>
-          <a:prstGeom prst="rect">
-            <a:avLst/>
-          </a:prstGeom>
-          <a:noFill/>
-        </p:spPr>
-        <p:txBody>
-          <a:bodyPr wrap="square">
-            <a:spAutoFit/>
-          </a:bodyPr>
-          <a:lstStyle/>
-          <a:p>
-            <a:pPr algn="ctr">
-              <a:defRPr sz="2000" b="1"/>
-            </a:pPr>
-            <a:r>
-              <a:t>Figure 6: Three Approaches to Causal Inference</a:t>
-            </a:r>
-          </a:p>
-        </p:txBody>
-      </p:sp>
-      <p:pic>
-        <p:nvPicPr>
-          <p:cNvPr id="3" name="Picture 2" descr="fig1_three_approaches.png"/>
-          <p:cNvPicPr>
-            <a:picLocks noChangeAspect="1"/>
-          </p:cNvPicPr>
-          <p:nvPr/>
-        </p:nvPicPr>
-        <p:blipFill>
-          <a:blip r:embed="rId2"/>
-          <a:stretch>
-            <a:fillRect/>
-          </a:stretch>
-        </p:blipFill>
-        <p:spPr>
-          <a:xfrm>
-            <a:off x="1371600" y="914400"/>
-            <a:ext cx="9448495" cy="4572000"/>
-          </a:xfrm>
-          <a:prstGeom prst="rect">
-            <a:avLst/>
-          </a:prstGeom>
-        </p:spPr>
-      </p:pic>
-      <p:sp>
-        <p:nvSpPr>
-          <p:cNvPr id="4" name="TextBox 3"/>
-          <p:cNvSpPr txBox="1"/>
-          <p:nvPr/>
-        </p:nvSpPr>
-        <p:spPr>
-          <a:xfrm>
-            <a:off x="457200" y="5669280"/>
-            <a:ext cx="11277295" cy="914400"/>
-          </a:xfrm>
-          <a:prstGeom prst="rect">
-            <a:avLst/>
-          </a:prstGeom>
-          <a:noFill/>
-        </p:spPr>
-        <p:txBody>
-          <a:bodyPr wrap="square">
-            <a:spAutoFit/>
-          </a:bodyPr>
-          <a:lstStyle/>
-          <a:p>
-            <a:pPr algn="ctr">
-              <a:defRPr sz="1200" i="1"/>
-            </a:pPr>
-            <a:r>
-              <a:t>Three approaches to causal inference on the same dataset. (A) LiNGAM DAG (6 edges). (B) Spectral causality at alpha=0.6 (10 directed edges, cycles allowed). (C) Spectral causality at alpha=0 with DPI (9 directed edges, no domain knowledge).</a:t>
-            </a:r>
-          </a:p>
-        </p:txBody>
-      </p:sp>
-    </p:spTree>
-  </p:cSld>
-  <p:clrMapOvr>
-    <a:masterClrMapping/>
-  </p:clrMapOvr>
-</p:sld>
-</file>
-
-<file path=ppt/slides/slide7.xml><?xml version="1.0" encoding="utf-8"?>
-<p:sld xmlns:a="http://schemas.openxmlformats.org/drawingml/2006/main" xmlns:p="http://schemas.openxmlformats.org/presentationml/2006/main" xmlns:r="http://schemas.openxmlformats.org/officeDocument/2006/relationships">
-  <p:cSld>
-    <p:spTree>
-      <p:nvGrpSpPr>
-        <p:cNvPr id="1" name=""/>
-        <p:cNvGrpSpPr/>
-        <p:nvPr/>
-      </p:nvGrpSpPr>
-      <p:grpSpPr/>
-      <p:sp>
-        <p:nvSpPr>
-          <p:cNvPr id="2" name="TextBox 1"/>
-          <p:cNvSpPr txBox="1"/>
-          <p:nvPr/>
-        </p:nvSpPr>
-        <p:spPr>
-          <a:xfrm>
-            <a:off x="457200" y="182880"/>
-            <a:ext cx="11277295" cy="548640"/>
-          </a:xfrm>
-          <a:prstGeom prst="rect">
-            <a:avLst/>
-          </a:prstGeom>
-          <a:noFill/>
-        </p:spPr>
-        <p:txBody>
-          <a:bodyPr wrap="square">
-            <a:spAutoFit/>
-          </a:bodyPr>
-          <a:lstStyle/>
-          <a:p>
-            <a:pPr algn="ctr">
-              <a:defRPr sz="2000" b="1"/>
-            </a:pPr>
-            <a:r>
-              <a:t>Figure 7: Three-Condition Structural Comparison</a:t>
-            </a:r>
-          </a:p>
-        </p:txBody>
-      </p:sp>
-      <p:pic>
-        <p:nvPicPr>
-          <p:cNvPr id="3" name="Picture 2" descr="fig7_lingam_vs_spectral.png"/>
-          <p:cNvPicPr>
-            <a:picLocks noChangeAspect="1"/>
-          </p:cNvPicPr>
-          <p:nvPr/>
-        </p:nvPicPr>
-        <p:blipFill>
-          <a:blip r:embed="rId2"/>
-          <a:stretch>
-            <a:fillRect/>
-          </a:stretch>
-        </p:blipFill>
-        <p:spPr>
-          <a:xfrm>
-            <a:off x="1371600" y="914400"/>
-            <a:ext cx="9448495" cy="4572000"/>
-          </a:xfrm>
-          <a:prstGeom prst="rect">
-            <a:avLst/>
-          </a:prstGeom>
-        </p:spPr>
-      </p:pic>
-      <p:sp>
-        <p:nvSpPr>
-          <p:cNvPr id="4" name="TextBox 3"/>
-          <p:cNvSpPr txBox="1"/>
-          <p:nvPr/>
-        </p:nvSpPr>
-        <p:spPr>
-          <a:xfrm>
-            <a:off x="457200" y="5669280"/>
-            <a:ext cx="11277295" cy="914400"/>
-          </a:xfrm>
-          <a:prstGeom prst="rect">
-            <a:avLst/>
-          </a:prstGeom>
-          <a:noFill/>
-        </p:spPr>
-        <p:txBody>
-          <a:bodyPr wrap="square">
-            <a:spAutoFit/>
-          </a:bodyPr>
-          <a:lstStyle/>
-          <a:p>
-            <a:pPr algn="ctr">
-              <a:defRPr sz="1200" i="1"/>
-            </a:pPr>
-            <a:r>
-              <a:t>Three-condition comparison. (A) LiNGAM DAG. (B) Spectral causality at alpha=0.6. (C) Spectral causality at alpha=0 with DPI.</a:t>
-            </a:r>
-          </a:p>
-        </p:txBody>
-      </p:sp>
-    </p:spTree>
-  </p:cSld>
-  <p:clrMapOvr>
-    <a:masterClrMapping/>
-  </p:clrMapOvr>
-</p:sld>
-</file>
-
-<file path=ppt/slides/slide8.xml><?xml version="1.0" encoding="utf-8"?>
-<p:sld xmlns:a="http://schemas.openxmlformats.org/drawingml/2006/main" xmlns:p="http://schemas.openxmlformats.org/presentationml/2006/main" xmlns:r="http://schemas.openxmlformats.org/officeDocument/2006/relationships">
-  <p:cSld>
-    <p:spTree>
-      <p:nvGrpSpPr>
-        <p:cNvPr id="1" name=""/>
-        <p:cNvGrpSpPr/>
-        <p:nvPr/>
-      </p:nvGrpSpPr>
-      <p:grpSpPr/>
-      <p:sp>
-        <p:nvSpPr>
-          <p:cNvPr id="2" name="TextBox 1"/>
-          <p:cNvSpPr txBox="1"/>
-          <p:nvPr/>
-        </p:nvSpPr>
-        <p:spPr>
-          <a:xfrm>
-            <a:off x="457200" y="182880"/>
-            <a:ext cx="11277295" cy="548640"/>
-          </a:xfrm>
-          <a:prstGeom prst="rect">
-            <a:avLst/>
-          </a:prstGeom>
-          <a:noFill/>
-        </p:spPr>
-        <p:txBody>
-          <a:bodyPr wrap="square">
-            <a:spAutoFit/>
-          </a:bodyPr>
-          <a:lstStyle/>
-          <a:p>
-            <a:pPr algn="ctr">
-              <a:defRPr sz="2000" b="1"/>
-            </a:pPr>
-            <a:r>
-              <a:t>Figure 8: Alpha-Sweep Analysis with DPI</a:t>
+              <a:t>Figure 4: Alpha-Sweep Phase Transition Analysis</a:t>
             </a:r>
           </a:p>
         </p:txBody>
@@ -3906,110 +3485,6 @@
             </a:pPr>
             <a:r>
               <a:t>Alpha-sweep analysis with DPI. (A) r_gradient increases smoothly from 0.581 (alpha=0) to 0.859 (alpha=1). (B) Number of detected edges and LiNGAM agreement rate. (C) Asymmetric norm. (D) Phase diagram.</a:t>
-            </a:r>
-          </a:p>
-        </p:txBody>
-      </p:sp>
-    </p:spTree>
-  </p:cSld>
-  <p:clrMapOvr>
-    <a:masterClrMapping/>
-  </p:clrMapOvr>
-</p:sld>
-</file>
-
-<file path=ppt/slides/slide9.xml><?xml version="1.0" encoding="utf-8"?>
-<p:sld xmlns:a="http://schemas.openxmlformats.org/drawingml/2006/main" xmlns:p="http://schemas.openxmlformats.org/presentationml/2006/main" xmlns:r="http://schemas.openxmlformats.org/officeDocument/2006/relationships">
-  <p:cSld>
-    <p:spTree>
-      <p:nvGrpSpPr>
-        <p:cNvPr id="1" name=""/>
-        <p:cNvGrpSpPr/>
-        <p:nvPr/>
-      </p:nvGrpSpPr>
-      <p:grpSpPr/>
-      <p:sp>
-        <p:nvSpPr>
-          <p:cNvPr id="2" name="TextBox 1"/>
-          <p:cNvSpPr txBox="1"/>
-          <p:nvPr/>
-        </p:nvSpPr>
-        <p:spPr>
-          <a:xfrm>
-            <a:off x="457200" y="182880"/>
-            <a:ext cx="11277295" cy="548640"/>
-          </a:xfrm>
-          <a:prstGeom prst="rect">
-            <a:avLst/>
-          </a:prstGeom>
-          <a:noFill/>
-        </p:spPr>
-        <p:txBody>
-          <a:bodyPr wrap="square">
-            <a:spAutoFit/>
-          </a:bodyPr>
-          <a:lstStyle/>
-          <a:p>
-            <a:pPr algn="ctr">
-              <a:defRPr sz="2000" b="1"/>
-            </a:pPr>
-            <a:r>
-              <a:t>Figure 9: ECD Pipeline Analysis</a:t>
-            </a:r>
-          </a:p>
-        </p:txBody>
-      </p:sp>
-      <p:pic>
-        <p:nvPicPr>
-          <p:cNvPr id="3" name="Picture 2" descr="fig9_ecd_pruning_analysis.png"/>
-          <p:cNvPicPr>
-            <a:picLocks noChangeAspect="1"/>
-          </p:cNvPicPr>
-          <p:nvPr/>
-        </p:nvPicPr>
-        <p:blipFill>
-          <a:blip r:embed="rId2"/>
-          <a:stretch>
-            <a:fillRect/>
-          </a:stretch>
-        </p:blipFill>
-        <p:spPr>
-          <a:xfrm>
-            <a:off x="1371600" y="914400"/>
-            <a:ext cx="9448495" cy="4572000"/>
-          </a:xfrm>
-          <a:prstGeom prst="rect">
-            <a:avLst/>
-          </a:prstGeom>
-        </p:spPr>
-      </p:pic>
-      <p:sp>
-        <p:nvSpPr>
-          <p:cNvPr id="4" name="TextBox 3"/>
-          <p:cNvSpPr txBox="1"/>
-          <p:nvPr/>
-        </p:nvSpPr>
-        <p:spPr>
-          <a:xfrm>
-            <a:off x="457200" y="5669280"/>
-            <a:ext cx="11277295" cy="914400"/>
-          </a:xfrm>
-          <a:prstGeom prst="rect">
-            <a:avLst/>
-          </a:prstGeom>
-          <a:noFill/>
-        </p:spPr>
-        <p:txBody>
-          <a:bodyPr wrap="square">
-            <a:spAutoFit/>
-          </a:bodyPr>
-          <a:lstStyle/>
-          <a:p>
-            <a:pPr algn="ctr">
-              <a:defRPr sz="1200" i="1"/>
-            </a:pPr>
-            <a:r>
-              <a:t>ECD pipeline analysis. (A) Hodge decomposition of ECD flow. (B) Causal potential phi vs. interventionability iota. (C) Per-edge feedback ratio. (D) U-shaped curve of r_gradient vs. knowledge quality p_flip.</a:t>
             </a:r>
           </a:p>
         </p:txBody>

</xml_diff>

<commit_message>
Add 3 new figures from session 2f832eb3: DPI architecture, CCI complex plane, p_flip U-curve
- A1 now has 7 figures (existing 4 + 3 new), renumbered by document order
- fig_dpi_architecture.png: DPI modular architecture block diagram (§4.2)
- fig_cci_complex_plane.png: CCI variable pairs in complex plane (§4.4)
- fig_pflip_ucurve.png: knowledge quality phase transition U-curve (§8.2)
- LaTeX: 25 pages, 0 undefined references, 7 figures with text citations
- docx/pptx: regenerated with sequential numbering (Fig 1-7)
- All figures cited in text before placement per JMLR requirements

Co-Authored-By: Tatsuki Onishi <bougtoir@gmail.com>
</commit_message>
<xml_diff>
--- a/spectral-causality-jmlr/spectral_causality_figures.pptx
+++ b/spectral-causality-jmlr/spectral_causality_figures.pptx
@@ -9,6 +9,9 @@
     <p:sldId id="257" r:id="rId8"/>
     <p:sldId id="258" r:id="rId9"/>
     <p:sldId id="259" r:id="rId10"/>
+    <p:sldId id="260" r:id="rId11"/>
+    <p:sldId id="261" r:id="rId12"/>
+    <p:sldId id="262" r:id="rId13"/>
   </p:sldIdLst>
   <p:sldSz cx="12191695" cy="6858000" type="screen4x3"/>
   <p:notesSz cx="6858000" cy="9144000"/>
@@ -3221,14 +3224,14 @@
               <a:defRPr sz="2000" b="1"/>
             </a:pPr>
             <a:r>
-              <a:t>Figure 2: Magnetic Laplacian Eigenvectors in Complex Plane</a:t>
+              <a:t>Figure 2: DPI Architecture</a:t>
             </a:r>
           </a:p>
         </p:txBody>
       </p:sp>
       <p:pic>
         <p:nvPicPr>
-          <p:cNvPr id="3" name="Picture 2" descr="fig2_magnetic_laplacian_q.png"/>
+          <p:cNvPr id="3" name="Picture 2" descr="fig_dpi_architecture.png"/>
           <p:cNvPicPr>
             <a:picLocks noChangeAspect="1"/>
           </p:cNvPicPr>
@@ -3276,7 +3279,7 @@
               <a:defRPr sz="1200" i="1"/>
             </a:pPr>
             <a:r>
-              <a:t>Fiedler eigenvector of the magnetic Laplacian plotted in the complex plane for q=0, 0.1, and 0.25. At q=0, all points lie on the real axis. As q increases, variables spread into the complex plane, with phase angle ordering reflecting causal flow direction.</a:t>
+              <a:t>Architecture of the Directional Predictability Index (DPI). Three independent asymmetric statistics (regression coefficient asymmetry, ANM residual independence, conditional entropy reduction) are normalized and averaged. The composite asymmetric score modulates the symmetric correlation into the directional DPI.</a:t>
             </a:r>
           </a:p>
         </p:txBody>
@@ -3325,14 +3328,14 @@
               <a:defRPr sz="2000" b="1"/>
             </a:pPr>
             <a:r>
-              <a:t>Figure 3: Hodge Decomposition Results</a:t>
+              <a:t>Figure 3: Complex Causal Index in the Complex Plane</a:t>
             </a:r>
           </a:p>
         </p:txBody>
       </p:sp>
       <p:pic>
         <p:nvPicPr>
-          <p:cNvPr id="3" name="Picture 2" descr="fig3_hodge_decomposition.png"/>
+          <p:cNvPr id="3" name="Picture 2" descr="fig_cci_complex_plane.png"/>
           <p:cNvPicPr>
             <a:picLocks noChangeAspect="1"/>
           </p:cNvPicPr>
@@ -3380,7 +3383,7 @@
               <a:defRPr sz="1200" i="1"/>
             </a:pPr>
             <a:r>
-              <a:t>Hodge decomposition results. (A) 85.9% of flow energy is in the gradient (DAG) component; 14.1% is in the curl (feedback) component. (B) Causal potential phi: Age is most upstream; ST Depression is most downstream.</a:t>
+              <a:t>CCI(i,j) for all variable pairs plotted in the complex plane. Real axis = SCC (coupling strength); imaginary axis = SCD (causal direction). Red = forward direction (i -&gt; j); blue = reverse. Most pairs cluster in the lower half-plane, reflecting Age's dominance as the upstream root node.</a:t>
             </a:r>
           </a:p>
         </p:txBody>
@@ -3429,7 +3432,319 @@
               <a:defRPr sz="2000" b="1"/>
             </a:pPr>
             <a:r>
-              <a:t>Figure 4: Alpha-Sweep Phase Transition Analysis</a:t>
+              <a:t>Figure 4: Magnetic Laplacian Eigenvectors in Complex Plane</a:t>
+            </a:r>
+          </a:p>
+        </p:txBody>
+      </p:sp>
+      <p:pic>
+        <p:nvPicPr>
+          <p:cNvPr id="3" name="Picture 2" descr="fig2_magnetic_laplacian_q.png"/>
+          <p:cNvPicPr>
+            <a:picLocks noChangeAspect="1"/>
+          </p:cNvPicPr>
+          <p:nvPr/>
+        </p:nvPicPr>
+        <p:blipFill>
+          <a:blip r:embed="rId2"/>
+          <a:stretch>
+            <a:fillRect/>
+          </a:stretch>
+        </p:blipFill>
+        <p:spPr>
+          <a:xfrm>
+            <a:off x="1371600" y="914400"/>
+            <a:ext cx="9448495" cy="4572000"/>
+          </a:xfrm>
+          <a:prstGeom prst="rect">
+            <a:avLst/>
+          </a:prstGeom>
+        </p:spPr>
+      </p:pic>
+      <p:sp>
+        <p:nvSpPr>
+          <p:cNvPr id="4" name="TextBox 3"/>
+          <p:cNvSpPr txBox="1"/>
+          <p:nvPr/>
+        </p:nvSpPr>
+        <p:spPr>
+          <a:xfrm>
+            <a:off x="457200" y="5669280"/>
+            <a:ext cx="11277295" cy="914400"/>
+          </a:xfrm>
+          <a:prstGeom prst="rect">
+            <a:avLst/>
+          </a:prstGeom>
+          <a:noFill/>
+        </p:spPr>
+        <p:txBody>
+          <a:bodyPr wrap="square">
+            <a:spAutoFit/>
+          </a:bodyPr>
+          <a:lstStyle/>
+          <a:p>
+            <a:pPr algn="ctr">
+              <a:defRPr sz="1200" i="1"/>
+            </a:pPr>
+            <a:r>
+              <a:t>Fiedler eigenvector of the magnetic Laplacian plotted in the complex plane for q=0, 0.1, and 0.25. At q=0, all points lie on the real axis. As q increases, variables spread into the complex plane, with phase angle ordering reflecting causal flow direction.</a:t>
+            </a:r>
+          </a:p>
+        </p:txBody>
+      </p:sp>
+    </p:spTree>
+  </p:cSld>
+  <p:clrMapOvr>
+    <a:masterClrMapping/>
+  </p:clrMapOvr>
+</p:sld>
+</file>
+
+<file path=ppt/slides/slide5.xml><?xml version="1.0" encoding="utf-8"?>
+<p:sld xmlns:a="http://schemas.openxmlformats.org/drawingml/2006/main" xmlns:p="http://schemas.openxmlformats.org/presentationml/2006/main" xmlns:r="http://schemas.openxmlformats.org/officeDocument/2006/relationships">
+  <p:cSld>
+    <p:spTree>
+      <p:nvGrpSpPr>
+        <p:cNvPr id="1" name=""/>
+        <p:cNvGrpSpPr/>
+        <p:nvPr/>
+      </p:nvGrpSpPr>
+      <p:grpSpPr/>
+      <p:sp>
+        <p:nvSpPr>
+          <p:cNvPr id="2" name="TextBox 1"/>
+          <p:cNvSpPr txBox="1"/>
+          <p:nvPr/>
+        </p:nvSpPr>
+        <p:spPr>
+          <a:xfrm>
+            <a:off x="457200" y="182880"/>
+            <a:ext cx="11277295" cy="548640"/>
+          </a:xfrm>
+          <a:prstGeom prst="rect">
+            <a:avLst/>
+          </a:prstGeom>
+          <a:noFill/>
+        </p:spPr>
+        <p:txBody>
+          <a:bodyPr wrap="square">
+            <a:spAutoFit/>
+          </a:bodyPr>
+          <a:lstStyle/>
+          <a:p>
+            <a:pPr algn="ctr">
+              <a:defRPr sz="2000" b="1"/>
+            </a:pPr>
+            <a:r>
+              <a:t>Figure 5: Hodge Decomposition Results</a:t>
+            </a:r>
+          </a:p>
+        </p:txBody>
+      </p:sp>
+      <p:pic>
+        <p:nvPicPr>
+          <p:cNvPr id="3" name="Picture 2" descr="fig3_hodge_decomposition.png"/>
+          <p:cNvPicPr>
+            <a:picLocks noChangeAspect="1"/>
+          </p:cNvPicPr>
+          <p:nvPr/>
+        </p:nvPicPr>
+        <p:blipFill>
+          <a:blip r:embed="rId2"/>
+          <a:stretch>
+            <a:fillRect/>
+          </a:stretch>
+        </p:blipFill>
+        <p:spPr>
+          <a:xfrm>
+            <a:off x="1371600" y="914400"/>
+            <a:ext cx="9448495" cy="4572000"/>
+          </a:xfrm>
+          <a:prstGeom prst="rect">
+            <a:avLst/>
+          </a:prstGeom>
+        </p:spPr>
+      </p:pic>
+      <p:sp>
+        <p:nvSpPr>
+          <p:cNvPr id="4" name="TextBox 3"/>
+          <p:cNvSpPr txBox="1"/>
+          <p:nvPr/>
+        </p:nvSpPr>
+        <p:spPr>
+          <a:xfrm>
+            <a:off x="457200" y="5669280"/>
+            <a:ext cx="11277295" cy="914400"/>
+          </a:xfrm>
+          <a:prstGeom prst="rect">
+            <a:avLst/>
+          </a:prstGeom>
+          <a:noFill/>
+        </p:spPr>
+        <p:txBody>
+          <a:bodyPr wrap="square">
+            <a:spAutoFit/>
+          </a:bodyPr>
+          <a:lstStyle/>
+          <a:p>
+            <a:pPr algn="ctr">
+              <a:defRPr sz="1200" i="1"/>
+            </a:pPr>
+            <a:r>
+              <a:t>Hodge decomposition results. (A) 85.9% of flow energy is in the gradient (DAG) component; 14.1% is in the curl (feedback) component. (B) Causal potential phi: Age is most upstream; ST Depression is most downstream.</a:t>
+            </a:r>
+          </a:p>
+        </p:txBody>
+      </p:sp>
+    </p:spTree>
+  </p:cSld>
+  <p:clrMapOvr>
+    <a:masterClrMapping/>
+  </p:clrMapOvr>
+</p:sld>
+</file>
+
+<file path=ppt/slides/slide6.xml><?xml version="1.0" encoding="utf-8"?>
+<p:sld xmlns:a="http://schemas.openxmlformats.org/drawingml/2006/main" xmlns:p="http://schemas.openxmlformats.org/presentationml/2006/main" xmlns:r="http://schemas.openxmlformats.org/officeDocument/2006/relationships">
+  <p:cSld>
+    <p:spTree>
+      <p:nvGrpSpPr>
+        <p:cNvPr id="1" name=""/>
+        <p:cNvGrpSpPr/>
+        <p:nvPr/>
+      </p:nvGrpSpPr>
+      <p:grpSpPr/>
+      <p:sp>
+        <p:nvSpPr>
+          <p:cNvPr id="2" name="TextBox 1"/>
+          <p:cNvSpPr txBox="1"/>
+          <p:nvPr/>
+        </p:nvSpPr>
+        <p:spPr>
+          <a:xfrm>
+            <a:off x="457200" y="182880"/>
+            <a:ext cx="11277295" cy="548640"/>
+          </a:xfrm>
+          <a:prstGeom prst="rect">
+            <a:avLst/>
+          </a:prstGeom>
+          <a:noFill/>
+        </p:spPr>
+        <p:txBody>
+          <a:bodyPr wrap="square">
+            <a:spAutoFit/>
+          </a:bodyPr>
+          <a:lstStyle/>
+          <a:p>
+            <a:pPr algn="ctr">
+              <a:defRPr sz="2000" b="1"/>
+            </a:pPr>
+            <a:r>
+              <a:t>Figure 6: Knowledge Quality Phase Transition</a:t>
+            </a:r>
+          </a:p>
+        </p:txBody>
+      </p:sp>
+      <p:pic>
+        <p:nvPicPr>
+          <p:cNvPr id="3" name="Picture 2" descr="fig_pflip_ucurve.png"/>
+          <p:cNvPicPr>
+            <a:picLocks noChangeAspect="1"/>
+          </p:cNvPicPr>
+          <p:nvPr/>
+        </p:nvPicPr>
+        <p:blipFill>
+          <a:blip r:embed="rId2"/>
+          <a:stretch>
+            <a:fillRect/>
+          </a:stretch>
+        </p:blipFill>
+        <p:spPr>
+          <a:xfrm>
+            <a:off x="1371600" y="914400"/>
+            <a:ext cx="9448495" cy="4572000"/>
+          </a:xfrm>
+          <a:prstGeom prst="rect">
+            <a:avLst/>
+          </a:prstGeom>
+        </p:spPr>
+      </p:pic>
+      <p:sp>
+        <p:nvSpPr>
+          <p:cNvPr id="4" name="TextBox 3"/>
+          <p:cNvSpPr txBox="1"/>
+          <p:nvPr/>
+        </p:nvSpPr>
+        <p:spPr>
+          <a:xfrm>
+            <a:off x="457200" y="5669280"/>
+            <a:ext cx="11277295" cy="914400"/>
+          </a:xfrm>
+          <a:prstGeom prst="rect">
+            <a:avLst/>
+          </a:prstGeom>
+          <a:noFill/>
+        </p:spPr>
+        <p:txBody>
+          <a:bodyPr wrap="square">
+            <a:spAutoFit/>
+          </a:bodyPr>
+          <a:lstStyle/>
+          <a:p>
+            <a:pPr algn="ctr">
+              <a:defRPr sz="1200" i="1"/>
+            </a:pPr>
+            <a:r>
+              <a:t>U-shaped quality curve: r_gradient vs p_flip. Empirical results (200 trials, blue) closely match theoretical prediction (1-2p)^2 * r* (red dashed). Critical threshold p*_flip ~ 0.15: at least 85% correct directions needed. Partial misinformation is worse than complete ignorance.</a:t>
+            </a:r>
+          </a:p>
+        </p:txBody>
+      </p:sp>
+    </p:spTree>
+  </p:cSld>
+  <p:clrMapOvr>
+    <a:masterClrMapping/>
+  </p:clrMapOvr>
+</p:sld>
+</file>
+
+<file path=ppt/slides/slide7.xml><?xml version="1.0" encoding="utf-8"?>
+<p:sld xmlns:a="http://schemas.openxmlformats.org/drawingml/2006/main" xmlns:p="http://schemas.openxmlformats.org/presentationml/2006/main" xmlns:r="http://schemas.openxmlformats.org/officeDocument/2006/relationships">
+  <p:cSld>
+    <p:spTree>
+      <p:nvGrpSpPr>
+        <p:cNvPr id="1" name=""/>
+        <p:cNvGrpSpPr/>
+        <p:nvPr/>
+      </p:nvGrpSpPr>
+      <p:grpSpPr/>
+      <p:sp>
+        <p:nvSpPr>
+          <p:cNvPr id="2" name="TextBox 1"/>
+          <p:cNvSpPr txBox="1"/>
+          <p:nvPr/>
+        </p:nvSpPr>
+        <p:spPr>
+          <a:xfrm>
+            <a:off x="457200" y="182880"/>
+            <a:ext cx="11277295" cy="548640"/>
+          </a:xfrm>
+          <a:prstGeom prst="rect">
+            <a:avLst/>
+          </a:prstGeom>
+          <a:noFill/>
+        </p:spPr>
+        <p:txBody>
+          <a:bodyPr wrap="square">
+            <a:spAutoFit/>
+          </a:bodyPr>
+          <a:lstStyle/>
+          <a:p>
+            <a:pPr algn="ctr">
+              <a:defRPr sz="2000" b="1"/>
+            </a:pPr>
+            <a:r>
+              <a:t>Figure 7: Alpha-Sweep Phase Transition Analysis</a:t>
             </a:r>
           </a:p>
         </p:txBody>

</xml_diff>